<commit_message>
docs: add team member names (Rakhat, Danas, Nurlan)
Co-Authored-By: Claude Opus 5.5 <noreply@anthropic.com>
</commit_message>
<xml_diff>
--- a/deliverables/Project_Activity_1_Presentation.pptx
+++ b/deliverables/Project_Activity_1_Presentation.pptx
@@ -3945,7 +3945,7 @@
                 </a:solidFill>
                 <a:latin typeface="Calibri"/>
               </a:rPr>
-              <a:t>Student 1 · Student 2 · Student 3</a:t>
+              <a:t>Rakhat · Danas · Nurlan</a:t>
             </a:r>
           </a:p>
         </p:txBody>
@@ -7129,7 +7129,7 @@
                 </a:solidFill>
                 <a:latin typeface="Calibri"/>
               </a:rPr>
-              <a:t>S1</a:t>
+              <a:t>R</a:t>
             </a:r>
           </a:p>
         </p:txBody>
@@ -7168,7 +7168,7 @@
                 </a:solidFill>
                 <a:latin typeface="Cambria"/>
               </a:rPr>
-              <a:t>Student 1</a:t>
+              <a:t>Rakhat</a:t>
             </a:r>
           </a:p>
         </p:txBody>
@@ -7416,7 +7416,7 @@
                 </a:solidFill>
                 <a:latin typeface="Calibri"/>
               </a:rPr>
-              <a:t>S2</a:t>
+              <a:t>D</a:t>
             </a:r>
           </a:p>
         </p:txBody>
@@ -7455,7 +7455,7 @@
                 </a:solidFill>
                 <a:latin typeface="Cambria"/>
               </a:rPr>
-              <a:t>Student 2</a:t>
+              <a:t>Danas</a:t>
             </a:r>
           </a:p>
         </p:txBody>
@@ -7703,7 +7703,7 @@
                 </a:solidFill>
                 <a:latin typeface="Calibri"/>
               </a:rPr>
-              <a:t>S3</a:t>
+              <a:t>N</a:t>
             </a:r>
           </a:p>
         </p:txBody>
@@ -7742,7 +7742,7 @@
                 </a:solidFill>
                 <a:latin typeface="Cambria"/>
               </a:rPr>
-              <a:t>Student 3</a:t>
+              <a:t>Nurlan</a:t>
             </a:r>
           </a:p>
         </p:txBody>
@@ -10358,7 +10358,7 @@
         <p:spPr>
           <a:xfrm>
             <a:off x="3017520" y="4434840"/>
-            <a:ext cx="1280160" cy="274320"/>
+            <a:ext cx="1280160" cy="457200"/>
           </a:xfrm>
           <a:prstGeom prst="rect">
             <a:avLst/>
@@ -10383,7 +10383,23 @@
                 </a:solidFill>
                 <a:latin typeface="Calibri"/>
               </a:rPr>
-              <a:t>S2 storage</a:t>
+              <a:t>Danas</a:t>
+            </a:r>
+          </a:p>
+          <a:p>
+            <a:pPr algn="ctr">
+              <a:spcAft>
+                <a:spcPts val="600"/>
+              </a:spcAft>
+            </a:pPr>
+            <a:r>
+              <a:rPr sz="1100" b="0" i="0">
+                <a:solidFill>
+                  <a:srgbClr val="5B6B78"/>
+                </a:solidFill>
+                <a:latin typeface="Calibri"/>
+              </a:rPr>
+              <a:t>storage</a:t>
             </a:r>
           </a:p>
         </p:txBody>
@@ -10397,7 +10413,7 @@
         <p:spPr>
           <a:xfrm>
             <a:off x="4297680" y="4434840"/>
-            <a:ext cx="1280160" cy="274320"/>
+            <a:ext cx="1280160" cy="457200"/>
           </a:xfrm>
           <a:prstGeom prst="rect">
             <a:avLst/>
@@ -10422,7 +10438,23 @@
                 </a:solidFill>
                 <a:latin typeface="Calibri"/>
               </a:rPr>
-              <a:t>S1 api</a:t>
+              <a:t>Rakhat</a:t>
+            </a:r>
+          </a:p>
+          <a:p>
+            <a:pPr algn="ctr">
+              <a:spcAft>
+                <a:spcPts val="600"/>
+              </a:spcAft>
+            </a:pPr>
+            <a:r>
+              <a:rPr sz="1100" b="0" i="0">
+                <a:solidFill>
+                  <a:srgbClr val="5B6B78"/>
+                </a:solidFill>
+                <a:latin typeface="Calibri"/>
+              </a:rPr>
+              <a:t>api</a:t>
             </a:r>
           </a:p>
         </p:txBody>
@@ -10436,7 +10468,7 @@
         <p:spPr>
           <a:xfrm>
             <a:off x="5577840" y="4434840"/>
-            <a:ext cx="1280160" cy="274320"/>
+            <a:ext cx="1280160" cy="457200"/>
           </a:xfrm>
           <a:prstGeom prst="rect">
             <a:avLst/>
@@ -10461,7 +10493,23 @@
                 </a:solidFill>
                 <a:latin typeface="Calibri"/>
               </a:rPr>
-              <a:t>S3 docker-ci</a:t>
+              <a:t>Nurlan</a:t>
+            </a:r>
+          </a:p>
+          <a:p>
+            <a:pPr algn="ctr">
+              <a:spcAft>
+                <a:spcPts val="600"/>
+              </a:spcAft>
+            </a:pPr>
+            <a:r>
+              <a:rPr sz="1100" b="0" i="0">
+                <a:solidFill>
+                  <a:srgbClr val="5B6B78"/>
+                </a:solidFill>
+                <a:latin typeface="Calibri"/>
+              </a:rPr>
+              <a:t>docker-ci</a:t>
             </a:r>
           </a:p>
         </p:txBody>

</xml_diff>